<commit_message>
Redraw the three slide decks with the corrected renderer
Output of `python3 radar.py slides <run>/<repo> --lang vi`: Agent
Orchestrator 20 slides, Orca 27, oh-my-claudecode 34.

Co-Authored-By: Claude Sonnet 5.5 <noreply@anthropic.com>
Claude-Session: https://claude.ai/code/session_018JE9K762fSoWNQFEfNMvHx
</commit_message>
<xml_diff>
--- a/digests/2026-10-17-2/agent-orchestrator/slides-vi.pptx
+++ b/digests/2026-10-17-2/agent-orchestrator/slides-vi.pptx
@@ -5561,8 +5561,8 @@
         </p:nvSpPr>
         <p:spPr>
           <a:xfrm>
-            <a:off x="2184400" y="4170679"/>
-            <a:ext cx="7823200" cy="279401"/>
+            <a:off x="2184400" y="4105148"/>
+            <a:ext cx="7823200" cy="279400"/>
           </a:xfrm>
           <a:custGeom>
             <a:avLst/>
@@ -5571,15 +5571,15 @@
             <a:cxnLst/>
             <a:rect l="l" t="t" r="r" b="b"/>
             <a:pathLst>
-              <a:path w="7823200" h="279401">
+              <a:path w="7823200" h="279400">
                 <a:moveTo>
                   <a:pt x="7823200" y="0"/>
                 </a:moveTo>
                 <a:lnTo>
-                  <a:pt x="7823200" y="279401"/>
+                  <a:pt x="7823200" y="279400"/>
                 </a:lnTo>
                 <a:lnTo>
-                  <a:pt x="0" y="279401"/>
+                  <a:pt x="0" y="279400"/>
                 </a:lnTo>
                 <a:lnTo>
                   <a:pt x="0" y="0"/>
@@ -5612,12 +5612,12 @@
         </p:nvSpPr>
         <p:spPr>
           <a:xfrm>
-            <a:off x="685800" y="2947416"/>
-            <a:ext cx="2997200" cy="1223264"/>
+            <a:off x="685800" y="3012947"/>
+            <a:ext cx="2997200" cy="1092200"/>
           </a:xfrm>
           <a:prstGeom prst="roundRect">
             <a:avLst>
-              <a:gd name="adj" fmla="val 16611"/>
+              <a:gd name="adj" fmla="val 18604"/>
             </a:avLst>
           </a:prstGeom>
           <a:solidFill>
@@ -5645,8 +5645,8 @@
         </p:nvSpPr>
         <p:spPr>
           <a:xfrm>
-            <a:off x="863600" y="3049016"/>
-            <a:ext cx="2641600" cy="1020063"/>
+            <a:off x="863600" y="3114547"/>
+            <a:ext cx="2641600" cy="889000"/>
           </a:xfrm>
           <a:prstGeom prst="rect">
             <a:avLst/>
@@ -5684,12 +5684,12 @@
         </p:nvSpPr>
         <p:spPr>
           <a:xfrm>
-            <a:off x="4597400" y="2947416"/>
-            <a:ext cx="2997200" cy="1223264"/>
+            <a:off x="4597400" y="3012947"/>
+            <a:ext cx="2997200" cy="1092200"/>
           </a:xfrm>
           <a:prstGeom prst="roundRect">
             <a:avLst>
-              <a:gd name="adj" fmla="val 16611"/>
+              <a:gd name="adj" fmla="val 18604"/>
             </a:avLst>
           </a:prstGeom>
           <a:solidFill>
@@ -5717,8 +5717,8 @@
         </p:nvSpPr>
         <p:spPr>
           <a:xfrm>
-            <a:off x="4775200" y="3049016"/>
-            <a:ext cx="2641600" cy="1020063"/>
+            <a:off x="4775200" y="3114547"/>
+            <a:ext cx="2641600" cy="889000"/>
           </a:xfrm>
           <a:prstGeom prst="rect">
             <a:avLst/>
@@ -5756,12 +5756,12 @@
         </p:nvSpPr>
         <p:spPr>
           <a:xfrm>
-            <a:off x="8509000" y="2947416"/>
-            <a:ext cx="2997200" cy="1223264"/>
+            <a:off x="8509000" y="3012947"/>
+            <a:ext cx="2997200" cy="1092200"/>
           </a:xfrm>
           <a:prstGeom prst="roundRect">
             <a:avLst>
-              <a:gd name="adj" fmla="val 16611"/>
+              <a:gd name="adj" fmla="val 18604"/>
             </a:avLst>
           </a:prstGeom>
           <a:solidFill>
@@ -5789,8 +5789,8 @@
         </p:nvSpPr>
         <p:spPr>
           <a:xfrm>
-            <a:off x="8686800" y="3049016"/>
-            <a:ext cx="2641600" cy="1020063"/>
+            <a:off x="8686800" y="3114547"/>
+            <a:ext cx="2641600" cy="889000"/>
           </a:xfrm>
           <a:prstGeom prst="rect">
             <a:avLst/>

</xml_diff>